<commit_message>
Validate the DM-GAN baseline reproduction
</commit_message>
<xml_diff>
--- a/outputs/DM-GAN Baseline Implementation and Investigation - Session 6 Updated.pptx
+++ b/outputs/DM-GAN Baseline Implementation and Investigation - Session 6 Updated.pptx
@@ -2,22 +2,22 @@
 <file path=ppt/presentation.xml><?xml version="1.0" encoding="utf-8"?>
 <p:presentation xmlns:p="http://schemas.openxmlformats.org/presentationml/2006/main">
   <p:sldMasterIdLst>
-    <p:sldMasterId xmlns:r="http://schemas.openxmlformats.org/officeDocument/2006/relationships" id="2147483648" r:id="R572ae0d797804cc1"/>
+    <p:sldMasterId xmlns:r="http://schemas.openxmlformats.org/officeDocument/2006/relationships" id="2147483648" r:id="R6ef6bb3f761745b9"/>
   </p:sldMasterIdLst>
   <p:notesMasterIdLst>
-    <p:notesMasterId xmlns:r="http://schemas.openxmlformats.org/officeDocument/2006/relationships" r:id="R68a2e8ad543843eb"/>
+    <p:notesMasterId xmlns:r="http://schemas.openxmlformats.org/officeDocument/2006/relationships" r:id="R8351ccc5bf47415d"/>
   </p:notesMasterIdLst>
   <p:sldIdLst>
-    <p:sldId xmlns:r="http://schemas.openxmlformats.org/officeDocument/2006/relationships" id="256" r:id="R08f20320c1ae49c6"/>
-    <p:sldId xmlns:r="http://schemas.openxmlformats.org/officeDocument/2006/relationships" id="257" r:id="Rb1b523d6a7684fa3"/>
-    <p:sldId xmlns:r="http://schemas.openxmlformats.org/officeDocument/2006/relationships" id="258" r:id="R8ea730898124401f"/>
-    <p:sldId xmlns:r="http://schemas.openxmlformats.org/officeDocument/2006/relationships" id="259" r:id="R6d84c3e4edc94f88"/>
-    <p:sldId xmlns:r="http://schemas.openxmlformats.org/officeDocument/2006/relationships" id="260" r:id="Rf5028fe9800f4c08"/>
-    <p:sldId xmlns:r="http://schemas.openxmlformats.org/officeDocument/2006/relationships" id="261" r:id="Rb305bcf7a8dd4b89"/>
-    <p:sldId xmlns:r="http://schemas.openxmlformats.org/officeDocument/2006/relationships" id="262" r:id="R67f10c6f8b5f4bad"/>
-    <p:sldId xmlns:r="http://schemas.openxmlformats.org/officeDocument/2006/relationships" id="263" r:id="R245dc5c47bca4780"/>
-    <p:sldId xmlns:r="http://schemas.openxmlformats.org/officeDocument/2006/relationships" id="264" r:id="R9efb4c47e68b4e1a"/>
-    <p:sldId xmlns:r="http://schemas.openxmlformats.org/officeDocument/2006/relationships" id="265" r:id="R9808eada2b654a1d"/>
+    <p:sldId xmlns:r="http://schemas.openxmlformats.org/officeDocument/2006/relationships" id="256" r:id="R8e0abe96aed7469c"/>
+    <p:sldId xmlns:r="http://schemas.openxmlformats.org/officeDocument/2006/relationships" id="257" r:id="R87339061e8624d01"/>
+    <p:sldId xmlns:r="http://schemas.openxmlformats.org/officeDocument/2006/relationships" id="258" r:id="R0ac8e43e66114c27"/>
+    <p:sldId xmlns:r="http://schemas.openxmlformats.org/officeDocument/2006/relationships" id="259" r:id="R37f32b53f645484d"/>
+    <p:sldId xmlns:r="http://schemas.openxmlformats.org/officeDocument/2006/relationships" id="260" r:id="R9be44358388d4934"/>
+    <p:sldId xmlns:r="http://schemas.openxmlformats.org/officeDocument/2006/relationships" id="261" r:id="Rcd3c6fd1d6ce47a9"/>
+    <p:sldId xmlns:r="http://schemas.openxmlformats.org/officeDocument/2006/relationships" id="262" r:id="Rbbe20cce57da482a"/>
+    <p:sldId xmlns:r="http://schemas.openxmlformats.org/officeDocument/2006/relationships" id="263" r:id="Rd14cd90566d4497b"/>
+    <p:sldId xmlns:r="http://schemas.openxmlformats.org/officeDocument/2006/relationships" id="264" r:id="R7aaebe731e6641e4"/>
+    <p:sldId xmlns:r="http://schemas.openxmlformats.org/officeDocument/2006/relationships" id="265" r:id="R748c7d3dfee64989"/>
   </p:sldIdLst>
   <p:sldSz cx="9144000" cy="5143500"/>
   <p:notesSz cx="6858000" cy="9144000"/>
@@ -574,7 +574,7 @@
           <a:lstStyle xmlns:a="http://schemas.openxmlformats.org/drawingml/2006/main"/>
           <a:p xmlns:a="http://schemas.openxmlformats.org/drawingml/2006/main">
             <a:r>
-              <a:t>Close with the concrete outcome: the runtime path is verified and reproducible. The next decision is how much training budget to allocate before enabling the optional part-aware loss for a controlled comparison.</a:t>
+              <a:t>Close with the decision boundary. This week answers whether the baseline reproduction is reasonable: yes, on comparable FID and R-precision. Next week is a separate equal-budget experiment to determine whether part-aware alignment improves the baseline without materially worsening FID.</a:t>
             </a:r>
             <a:endParaRPr/>
           </a:p>
@@ -592,19 +592,13 @@
           </a:p>
           <a:p xmlns:a="http://schemas.openxmlformats.org/drawingml/2006/main">
             <a:r>
+              <a:t>Formal evaluation report: /home/zjk/Desktop/DM-GANS/artifacts/session6/baseline_evaluation/report.json</a:t>
+            </a:r>
+            <a:endParaRPr/>
+          </a:p>
+          <a:p xmlns:a="http://schemas.openxmlformats.org/drawingml/2006/main">
+            <a:r>
               <a:t>Session 6 checklist: /home/zjk/Desktop/DM-GANS/docs/session6_checklist.md</a:t>
-            </a:r>
-            <a:endParaRPr/>
-          </a:p>
-          <a:p xmlns:a="http://schemas.openxmlformats.org/drawingml/2006/main">
-            <a:r>
-              <a:t>Short-run summary: /home/zjk/Desktop/DM-GANS/artifacts/session6/short_run/summary.json</a:t>
-            </a:r>
-            <a:endParaRPr/>
-          </a:p>
-          <a:p xmlns:a="http://schemas.openxmlformats.org/drawingml/2006/main">
-            <a:r>
-              <a:t>DM-GAN official repository: https://github.com/MinfengZhu/DM-GAN</a:t>
             </a:r>
             <a:endParaRPr/>
           </a:p>
@@ -1126,7 +1120,7 @@
           <a:lstStyle xmlns:a="http://schemas.openxmlformats.org/drawingml/2006/main"/>
           <a:p xmlns:a="http://schemas.openxmlformats.org/drawingml/2006/main">
             <a:r>
-              <a:t>The image on the left was generated locally using the official pretrained DM-GAN checkpoint. The metric table remains a reference table and is not a local result. Emphasize the separation among official checkpoint inference, the locally reimplemented random-init core, and paper/repository metrics.</a:t>
+              <a:t>Lead with the formal evidence: the author-released generator and DAMSM weights were loaded strictly and evaluated on 30,000 fixed CUB test samples through the modern code path. Comparable PyTorch FID and DAMSM R-precision both meet the predeclared pass bounds. The ImageNet Inception Score is a health check only; it is not comparable with the paper's legacy 50-class bird evaluator.</a:t>
             </a:r>
             <a:endParaRPr/>
           </a:p>
@@ -1144,19 +1138,13 @@
           </a:p>
           <a:p xmlns:a="http://schemas.openxmlformats.org/drawingml/2006/main">
             <a:r>
-              <a:t>Official checkpoint inference report: /home/zjk/Desktop/DM-GANS/artifacts/session6/official_pretrained/report.json</a:t>
-            </a:r>
-            <a:endParaRPr/>
-          </a:p>
-          <a:p xmlns:a="http://schemas.openxmlformats.org/drawingml/2006/main">
-            <a:r>
-              <a:t>Real integration report: /home/zjk/Desktop/DM-GANS/artifacts/session6/real_integration/report.json</a:t>
-            </a:r>
-            <a:endParaRPr/>
-          </a:p>
-          <a:p xmlns:a="http://schemas.openxmlformats.org/drawingml/2006/main">
-            <a:r>
-              <a:t>Short-run summary: /home/zjk/Desktop/DM-GANS/artifacts/session6/short_run/summary.json</a:t>
+              <a:t>Formal evaluation report: /home/zjk/Desktop/DM-GANS/artifacts/session6/baseline_evaluation/report.json</a:t>
+            </a:r>
+            <a:endParaRPr/>
+          </a:p>
+          <a:p xmlns:a="http://schemas.openxmlformats.org/drawingml/2006/main">
+            <a:r>
+              <a:t>Evaluation methodology: /home/zjk/Desktop/DM-GANS/artifacts/session6/baseline_evaluation/BASELINE_EVALUATION.md</a:t>
             </a:r>
             <a:endParaRPr/>
           </a:p>
@@ -1233,7 +1221,7 @@
           <a:lstStyle xmlns:a="http://schemas.openxmlformats.org/drawingml/2006/main"/>
           <a:p xmlns:a="http://schemas.openxmlformats.org/drawingml/2006/main">
             <a:r>
-              <a:t>The limitation claims come from a small hand-inspected set of 16 fixed prompts using the official checkpoint. They are qualitative signals, not benchmark statistics. The locally trained 200-step model only demonstrates training progress.</a:t>
+              <a:t>State the claim precisely: these results validate author-weight inference through the modern implementation. They do not show that the 200-step random-initialized checkpoint is a converged model and they do not test the part-aware proposal.</a:t>
             </a:r>
             <a:endParaRPr/>
           </a:p>
@@ -1251,19 +1239,13 @@
           </a:p>
           <a:p xmlns:a="http://schemas.openxmlformats.org/drawingml/2006/main">
             <a:r>
-              <a:t>Failure analysis: /home/zjk/Desktop/DM-GANS/docs/failure_analysis.md</a:t>
-            </a:r>
-            <a:endParaRPr/>
-          </a:p>
-          <a:p xmlns:a="http://schemas.openxmlformats.org/drawingml/2006/main">
-            <a:r>
-              <a:t>Diagnostic report: /home/zjk/Desktop/DM-GANS/artifacts/session6/diagnostics/red_wings/report.json</a:t>
-            </a:r>
-            <a:endParaRPr/>
-          </a:p>
-          <a:p xmlns:a="http://schemas.openxmlformats.org/drawingml/2006/main">
-            <a:r>
-              <a:t>Official 16-prompt report: /home/zjk/Desktop/DM-GANS/artifacts/session6/official_pretrained_16/report.json</a:t>
+              <a:t>Formal evaluation report: /home/zjk/Desktop/DM-GANS/artifacts/session6/baseline_evaluation/report.json</a:t>
+            </a:r>
+            <a:endParaRPr/>
+          </a:p>
+          <a:p xmlns:a="http://schemas.openxmlformats.org/drawingml/2006/main">
+            <a:r>
+              <a:t>Baseline completion record: /home/zjk/Desktop/DM-GANS/SESSION6_COMPLETION.md</a:t>
             </a:r>
             <a:endParaRPr/>
           </a:p>
@@ -1438,7 +1420,7 @@
   </p:cSld>
   <p:clrMap bg1="lt1" tx1="dk1" bg2="lt2" tx2="dk2" accent1="accent1" accent2="accent2" accent3="accent3" accent4="accent4" accent5="accent5" accent6="accent6" hlink="hlink" folHlink="folHlink"/>
   <p:sldLayoutIdLst>
-    <p:sldLayoutId xmlns:r="http://schemas.openxmlformats.org/officeDocument/2006/relationships" id="2147483649" r:id="R4547e04e13f8436e"/>
+    <p:sldLayoutId xmlns:r="http://schemas.openxmlformats.org/officeDocument/2006/relationships" id="2147483649" r:id="R25daceda1c1449a9"/>
   </p:sldLayoutIdLst>
   <p:hf sldNum="0" hdr="0" ftr="0" dt="0"/>
   <p:txStyles>
@@ -3353,7 +3335,7 @@
                 <a:ea typeface="Arial"/>
                 <a:cs typeface="Arial"/>
               </a:rPr>
-              <a:t>Next Run: Longer Baseline → Diagnosis → Ablation</a:t>
+              <a:t>Next Week: Part-Aware Ablation</a:t>
             </a:r>
             <a:endParaRPr sz="2100"/>
           </a:p>
@@ -3399,7 +3381,7 @@
                 <a:ea typeface="Arial"/>
                 <a:cs typeface="Arial"/>
               </a:rPr>
-              <a:t>End-to-end runtime works; remaining work is evidence at training scale</a:t>
+              <a:t>Baseline validated; improvement efficacy is the next controlled question</a:t>
             </a:r>
             <a:endParaRPr sz="1150"/>
           </a:p>
@@ -3572,11 +3554,11 @@
                 <a:ea typeface="Arial"/>
                 <a:cs typeface="Arial"/>
               </a:rPr>
-              <a:t>1. RTX 5080 · PyTorch 2.12
-2. CUB images + metadata loaded
-3. DAMSM + DM-GAN weights
-4. Inference + backprop passed
-5. 200-step run saved · batch 10</a:t>
+              <a:t>1. Strict official checkpoint load
+2. 30,000 fixed CUB samples
+3. FID 15.76 (reference 15.34)
+4. R-precision 76.67% (ref. 76.58%)
+5. Baseline verdict: PASS</a:t>
             </a:r>
             <a:endParaRPr sz="1200"/>
           </a:p>
@@ -3749,11 +3731,11 @@
                 <a:ea typeface="Arial"/>
                 <a:cs typeface="Arial"/>
               </a:rPr>
-              <a:t>① Extend baseline training with fixed prompts
-② Track G/D and DAMSM losses
-③ Expand the part-error taxonomy
-④ Enable part-aware loss behind a flag
-⑤ Run a fixed-budget ablation</a:t>
+              <a:t>① Freeze the evaluation protocol
+② Train equal-budget baseline/variant
+③ Track part-attribute accuracy
+④ Compare R-precision and FID
+⑤ Report trade-offs, not just wins</a:t>
             </a:r>
             <a:endParaRPr sz="1100"/>
           </a:p>
@@ -3890,7 +3872,7 @@
                 <a:ea typeface="Arial"/>
                 <a:cs typeface="Arial"/>
               </a:rPr>
-              <a:t>End-to-end baseline · one evaluator · higher R-precision/part accuracy without material FID regression</a:t>
+              <a:t>One evaluator · higher R-precision/part accuracy · no material FID regression</a:t>
             </a:r>
             <a:endParaRPr sz="1050"/>
           </a:p>
@@ -3975,7 +3957,7 @@
                 <a:ea typeface="Arial"/>
                 <a:cs typeface="Arial"/>
               </a:rPr>
-              <a:t>Session 6 outcome: the reproduction pipeline runs; full metrics and part-aware ablation are next.</a:t>
+              <a:t>This week: baseline reproduction passed. Next week: test whether part-aware alignment improves it.</a:t>
             </a:r>
             <a:endParaRPr sz="1100"/>
           </a:p>
@@ -4643,8 +4625,8 @@
               </a:rPr>
               <a:t>Can we reproduce the DM-GAN pipeline on CUB and verify whether dynamic memory repairs text–image mismatches when the initial image is weak?
 Milestone result:
-modern PyTorch core + official weights + real CUB backprop + 200-step short run.
-Pending: full training and local metrics.</a:t>
+modern core + official weights + real CUB backprop + 30,000-sample evaluation.
+Verdict: baseline reproduction passed; local from-scratch convergence remains pending.</a:t>
             </a:r>
             <a:endParaRPr sz="1300"/>
           </a:p>
@@ -5398,7 +5380,7 @@
                 <a:ea typeface="Arial"/>
                 <a:cs typeface="Arial"/>
               </a:rPr>
-              <a:t>Reproduction target: CUB with official DAMSM inputs. Official-checkpoint inference and real-batch backprop passed; full local training metrics remain pending.</a:t>
+              <a:t>Reproduction target: CUB with official DAMSM inputs. A 30,000-sample official-weight evaluation passed; local from-scratch convergence remains pending.</a:t>
             </a:r>
             <a:endParaRPr sz="1250"/>
           </a:p>
@@ -7101,7 +7083,7 @@
           <p:nvPr/>
         </p:nvPicPr>
         <p:blipFill>
-          <a:blip xmlns:r="http://schemas.openxmlformats.org/officeDocument/2006/relationships" xmlns:a="http://schemas.openxmlformats.org/drawingml/2006/main" r:embed="R2fa3d81ea7e34db5"/>
+          <a:blip xmlns:r="http://schemas.openxmlformats.org/officeDocument/2006/relationships" xmlns:a="http://schemas.openxmlformats.org/drawingml/2006/main" r:embed="R7633315e72f34f25"/>
           <a:srcRect xmlns:a="http://schemas.openxmlformats.org/drawingml/2006/main" l="0" t="0" r="0" b="0"/>
           <a:stretch xmlns:a="http://schemas.openxmlformats.org/drawingml/2006/main"/>
         </p:blipFill>
@@ -8500,7 +8482,7 @@
                 <a:ea typeface="Arial"/>
                 <a:cs typeface="Arial"/>
               </a:rPr>
-              <a:t>Verification Status: Runtime Path Passed</a:t>
+              <a:t>Baseline Reproduction: Comparable Metrics Pass</a:t>
             </a:r>
             <a:endParaRPr sz="2100"/>
           </a:p>
@@ -8546,7 +8528,7 @@
                 <a:ea typeface="Arial"/>
                 <a:cs typeface="Arial"/>
               </a:rPr>
-              <a:t>Local runs are separated from official-checkpoint and paper reference results</a:t>
+              <a:t>30,000 fixed CUB test samples · author weights through the modern code path</a:t>
             </a:r>
             <a:endParaRPr sz="1150"/>
           </a:p>
@@ -8994,7 +8976,7 @@
                 <a:ea typeface="Arial"/>
                 <a:cs typeface="Arial"/>
               </a:rPr>
-              <a:t>SHORT · TRAIN</a:t>
+              <a:t>EVAL · SCALE</a:t>
             </a:r>
             <a:endParaRPr sz="1100"/>
           </a:p>
@@ -9040,7 +9022,7 @@
                 <a:ea typeface="Arial"/>
                 <a:cs typeface="Arial"/>
               </a:rPr>
-              <a:t>200 STEPS</a:t>
+              <a:t>30,000</a:t>
             </a:r>
             <a:endParaRPr sz="1300"/>
           </a:p>
@@ -9086,7 +9068,7 @@
                 <a:ea typeface="Arial"/>
                 <a:cs typeface="Arial"/>
               </a:rPr>
-              <a:t>batch 10 · no metric</a:t>
+              <a:t>fixed test samples</a:t>
             </a:r>
             <a:endParaRPr sz="1000"/>
           </a:p>
@@ -9189,7 +9171,7 @@
           <p:nvPr/>
         </p:nvPicPr>
         <p:blipFill>
-          <a:blip xmlns:r="http://schemas.openxmlformats.org/officeDocument/2006/relationships" xmlns:a="http://schemas.openxmlformats.org/drawingml/2006/main" r:embed="R9512774747bd4604"/>
+          <a:blip xmlns:r="http://schemas.openxmlformats.org/officeDocument/2006/relationships" xmlns:a="http://schemas.openxmlformats.org/drawingml/2006/main" r:embed="R8b0ddb2aa6094451"/>
           <a:srcRect xmlns:a="http://schemas.openxmlformats.org/drawingml/2006/main" l="0" t="0" r="0" b="0"/>
           <a:stretch xmlns:a="http://schemas.openxmlformats.org/drawingml/2006/main"/>
         </p:blipFill>
@@ -9321,7 +9303,7 @@
                 <a:ea typeface="Arial"/>
                 <a:cs typeface="Arial"/>
               </a:rPr>
-              <a:t>Official CUB Reference</a:t>
+              <a:t>Official Pretrained Ref.</a:t>
             </a:r>
             <a:endParaRPr sz="1200"/>
           </a:p>
@@ -9481,7 +9463,7 @@
                 <a:ea typeface="Arial"/>
                 <a:cs typeface="Arial"/>
               </a:rPr>
-              <a:t>72.31%</a:t>
+              <a:t>76.58% ±0.53</a:t>
             </a:r>
             <a:endParaRPr sz="1000"/>
           </a:p>
@@ -9561,7 +9543,7 @@
                 <a:ea typeface="Arial"/>
                 <a:cs typeface="Arial"/>
               </a:rPr>
-              <a:t>Inception Score</a:t>
+              <a:t>PyTorch FID</a:t>
             </a:r>
             <a:endParaRPr sz="1000"/>
           </a:p>
@@ -9641,7 +9623,7 @@
                 <a:ea typeface="Arial"/>
                 <a:cs typeface="Arial"/>
               </a:rPr>
-              <a:t>4.75</a:t>
+              <a:t>15.34</a:t>
             </a:r>
             <a:endParaRPr sz="1000"/>
           </a:p>
@@ -9721,7 +9703,7 @@
                 <a:ea typeface="Arial"/>
                 <a:cs typeface="Arial"/>
               </a:rPr>
-              <a:t>FID (paper)</a:t>
+              <a:t>CUB IS (legacy)</a:t>
             </a:r>
             <a:endParaRPr sz="1000"/>
           </a:p>
@@ -9801,7 +9783,7 @@
                 <a:ea typeface="Arial"/>
                 <a:cs typeface="Arial"/>
               </a:rPr>
-              <a:t>16.09</a:t>
+              <a:t>4.71 ±0.06</a:t>
             </a:r>
             <a:endParaRPr sz="1000"/>
           </a:p>
@@ -9881,7 +9863,7 @@
                 <a:ea typeface="Arial"/>
                 <a:cs typeface="Arial"/>
               </a:rPr>
-              <a:t>Repo pretrained FID</a:t>
+              <a:t>Paper FID</a:t>
             </a:r>
             <a:endParaRPr sz="1000"/>
           </a:p>
@@ -9961,7 +9943,7 @@
                 <a:ea typeface="Arial"/>
                 <a:cs typeface="Arial"/>
               </a:rPr>
-              <a:t>15.34</a:t>
+              <a:t>16.09</a:t>
             </a:r>
             <a:endParaRPr sz="1000"/>
           </a:p>
@@ -10052,10 +10034,11 @@
                 <a:ea typeface="Arial"/>
                 <a:cs typeface="Arial"/>
               </a:rPr>
-              <a:t>Verified: CUB → DAMSM → G/D → loss → backprop.
-Runtime: RTX 5080 · PyTorch 2.12 + CUDA 13.
-Local: 200 steps, batch 10; checkpoint + loss log saved.
-Pending: full training and local metrics.</a:t>
+              <a:t>30,000 fixed samples · strict weights.
+FID: 15.76 vs 15.34 official.
+R-precision: 76.67% ±0.83 vs 76.58% ±0.53.
+Verdict: PASS.
+IS 5.70±0.09 uses ImageNet—not paper-comparable.</a:t>
             </a:r>
             <a:endParaRPr sz="1050"/>
           </a:p>
@@ -10324,7 +10307,7 @@
                 <a:ea typeface="Arial"/>
                 <a:cs typeface="Arial"/>
               </a:rPr>
-              <a:t>What the Baseline Investigation Revealed</a:t>
+              <a:t>What the Baseline Reproduction Proved</a:t>
             </a:r>
             <a:endParaRPr sz="2100"/>
           </a:p>
@@ -10370,7 +10353,7 @@
                 <a:ea typeface="Arial"/>
                 <a:cs typeface="Arial"/>
               </a:rPr>
-              <a:t>Reproduction barriers and model limitations require different fixes</a:t>
+              <a:t>Comparable metrics validate the modern inference path—not a new training recipe</a:t>
             </a:r>
             <a:endParaRPr sz="1150"/>
           </a:p>
@@ -10494,7 +10477,7 @@
                 <a:ea typeface="Arial"/>
                 <a:cs typeface="Arial"/>
               </a:rPr>
-              <a:t>Verified Implementation</a:t>
+              <a:t>Comparable Evaluation</a:t>
             </a:r>
             <a:endParaRPr sz="1250"/>
           </a:p>
@@ -10543,10 +10526,10 @@
                 <a:ea typeface="Arial"/>
                 <a:cs typeface="Arial"/>
               </a:rPr>
-              <a:t>✓ Official checkpoint inference passed
-✓ Modern core: 7 tests + full-width smoke
-✓ Real CUB batch completed full backprop
-✓ 200-step run: batch 10, checkpoint saved</a:t>
+              <a:t>✓ 30,000 fixed CUB test samples
+✓ PyTorch FID: 15.76 vs 15.34
+✓ R-precision: 76.67% vs 76.58%
+✓ Strict weights + full path: PASS</a:t>
             </a:r>
             <a:endParaRPr sz="1150"/>
           </a:p>
@@ -10670,7 +10653,7 @@
                 <a:ea typeface="Arial"/>
                 <a:cs typeface="Arial"/>
               </a:rPr>
-              <a:t>Observed Limitation</a:t>
+              <a:t>Interpretation Boundary</a:t>
             </a:r>
             <a:endParaRPr sz="1250"/>
           </a:p>
@@ -10719,8 +10702,8 @@
                 <a:ea typeface="Arial"/>
                 <a:cs typeface="Arial"/>
               </a:rPr>
-              <a:t>Official-checkpoint samples capture global color, but fine part relationships are less consistent.
-Eye rings, head color, wing/belly placement, and beak geometry need part-level evidence.</a:t>
+              <a:t>Author-weight inference through the modern code path is reproduced.
+The 200-step random-init checkpoint remains pipeline evidence—not a converged baseline.</a:t>
             </a:r>
             <a:endParaRPr sz="1150"/>
           </a:p>
@@ -10808,7 +10791,7 @@
                 <a:ea typeface="Arial"/>
                 <a:cs typeface="Arial"/>
               </a:rPr>
-              <a:t>Evidence Collected</a:t>
+              <a:t>Baseline Verdict</a:t>
             </a:r>
             <a:endParaRPr sz="1250"/>
           </a:p>
@@ -10857,7 +10840,7 @@
                 <a:ea typeface="Arial"/>
                 <a:cs typeface="Arial"/>
               </a:rPr>
-              <a:t>16 fixed-caption samples plus attention/writing-gate diagnostics. The 200-step local output shows colored structure only—not a quality result.</a:t>
+              <a:t>PASS: comparable FID and R-precision meet predeclared bounds. ImageNet IS 5.70±0.09 is separate because the paper used a legacy bird classifier.</a:t>
             </a:r>
             <a:endParaRPr sz="1150"/>
           </a:p>

</xml_diff>